<commit_message>
Judges deck: rooms no longer show a 3-2-1, so say same start, same course
</commit_message>
<xml_diff>
--- a/docs/duck-run-judges-deck.pptx
+++ b/docs/duck-run-judges-deck.pptx
@@ -1659,7 +1659,7 @@
           <a:p>
             <a:r>
               <a:rPr lang="en-US" dirty="0"/>
-              <a:t>And it’s built to play together, in the room. The host opens a room on the big screen. Everyone scans the QR code: no app, no account, just a name. You land in the pond as a Bill in your own suit. The host hits start, everyone gets the same 3-2-1 and the same course, on their own phone. Up to 20 players a room.</a:t>
+              <a:t>And it’s built to play together, in the room. The host opens a room on the big screen. Everyone scans the QR code: no app, no account, just a name. You land in the pond as a Bill in your own suit. The host hits start: the first race opens with the story, then everyone starts together on the same course, on their own phone. Up to 20 players a room.</a:t>
             </a:r>
             <a:endParaRPr lang="en-US" dirty="0"/>
           </a:p>
@@ -9833,7 +9833,7 @@
                 <a:ea typeface="Nunito Sans" pitchFamily="34" charset="-122"/>
                 <a:cs typeface="Nunito Sans" pitchFamily="34" charset="-120"/>
               </a:rPr>
-              <a:t>One 3-2-1, the same course for everyone.</a:t>
+              <a:t>Same start, same course for everyone.</a:t>
             </a:r>
             <a:endParaRPr lang="en-US" sz="1400" dirty="0"/>
           </a:p>

</xml_diff>